<commit_message>
Fix native PowerPoint title compositing
</commit_message>
<xml_diff>
--- a/Assets/PowerPointTemplates/PowerPointAdvancedRoadmap.pptx
+++ b/Assets/PowerPointTemplates/PowerPointAdvancedRoadmap.pptx
@@ -114,6 +114,11 @@
       </a:defRPr>
     </a:lvl9pPr>
   </p:defaultTextStyle>
+  <p:extLst>
+    <p:ext uri="{EFAFB233-063F-42B5-8137-9DF3F51BA10A}">
+      <p15:sldGuideLst xmlns:p15="http://schemas.microsoft.com/office/powerpoint/2012/main"/>
+    </p:ext>
+  </p:extLst>
 </p:presentation>
 </file>
 
@@ -1869,6 +1874,11 @@
                 </a:contourClr>
               </a:sp3d>
             </c:spPr>
+            <c:extLst>
+              <c:ext xmlns:c16="http://schemas.microsoft.com/office/drawing/2014/chart" uri="{C3380CC4-5D6E-409C-BE32-E72D297353CC}">
+                <c16:uniqueId val="{00000001-4C11-47F4-9C8E-1F36C9F5D903}"/>
+              </c:ext>
+            </c:extLst>
           </c:dPt>
           <c:dPt>
             <c:idx val="1"/>
@@ -1889,6 +1899,11 @@
                 </a:contourClr>
               </a:sp3d>
             </c:spPr>
+            <c:extLst>
+              <c:ext xmlns:c16="http://schemas.microsoft.com/office/drawing/2014/chart" uri="{C3380CC4-5D6E-409C-BE32-E72D297353CC}">
+                <c16:uniqueId val="{00000003-4C11-47F4-9C8E-1F36C9F5D903}"/>
+              </c:ext>
+            </c:extLst>
           </c:dPt>
           <c:dPt>
             <c:idx val="2"/>
@@ -1909,6 +1924,11 @@
                 </a:contourClr>
               </a:sp3d>
             </c:spPr>
+            <c:extLst>
+              <c:ext xmlns:c16="http://schemas.microsoft.com/office/drawing/2014/chart" uri="{C3380CC4-5D6E-409C-BE32-E72D297353CC}">
+                <c16:uniqueId val="{00000005-4C11-47F4-9C8E-1F36C9F5D903}"/>
+              </c:ext>
+            </c:extLst>
           </c:dPt>
           <c:dPt>
             <c:idx val="3"/>
@@ -1929,6 +1949,11 @@
                 </a:contourClr>
               </a:sp3d>
             </c:spPr>
+            <c:extLst>
+              <c:ext xmlns:c16="http://schemas.microsoft.com/office/drawing/2014/chart" uri="{C3380CC4-5D6E-409C-BE32-E72D297353CC}">
+                <c16:uniqueId val="{00000007-4C11-47F4-9C8E-1F36C9F5D903}"/>
+              </c:ext>
+            </c:extLst>
           </c:dPt>
           <c:cat>
             <c:strRef>
@@ -2163,6 +2188,11 @@
               </a:ln>
               <a:effectLst/>
             </c:spPr>
+            <c:extLst>
+              <c:ext xmlns:c16="http://schemas.microsoft.com/office/drawing/2014/chart" uri="{C3380CC4-5D6E-409C-BE32-E72D297353CC}">
+                <c16:uniqueId val="{00000001-315E-4F5F-9824-525B2026058B}"/>
+              </c:ext>
+            </c:extLst>
           </c:dPt>
           <c:dPt>
             <c:idx val="1"/>
@@ -2178,6 +2208,11 @@
               </a:ln>
               <a:effectLst/>
             </c:spPr>
+            <c:extLst>
+              <c:ext xmlns:c16="http://schemas.microsoft.com/office/drawing/2014/chart" uri="{C3380CC4-5D6E-409C-BE32-E72D297353CC}">
+                <c16:uniqueId val="{00000003-315E-4F5F-9824-525B2026058B}"/>
+              </c:ext>
+            </c:extLst>
           </c:dPt>
           <c:dPt>
             <c:idx val="2"/>
@@ -2193,6 +2228,11 @@
               </a:ln>
               <a:effectLst/>
             </c:spPr>
+            <c:extLst>
+              <c:ext xmlns:c16="http://schemas.microsoft.com/office/drawing/2014/chart" uri="{C3380CC4-5D6E-409C-BE32-E72D297353CC}">
+                <c16:uniqueId val="{00000005-315E-4F5F-9824-525B2026058B}"/>
+              </c:ext>
+            </c:extLst>
           </c:dPt>
           <c:dPt>
             <c:idx val="3"/>
@@ -2208,6 +2248,11 @@
               </a:ln>
               <a:effectLst/>
             </c:spPr>
+            <c:extLst>
+              <c:ext xmlns:c16="http://schemas.microsoft.com/office/drawing/2014/chart" uri="{C3380CC4-5D6E-409C-BE32-E72D297353CC}">
+                <c16:uniqueId val="{00000007-315E-4F5F-9824-525B2026058B}"/>
+              </c:ext>
+            </c:extLst>
           </c:dPt>
           <c:dPt>
             <c:idx val="4"/>
@@ -2223,6 +2268,11 @@
               </a:ln>
               <a:effectLst/>
             </c:spPr>
+            <c:extLst>
+              <c:ext xmlns:c16="http://schemas.microsoft.com/office/drawing/2014/chart" uri="{C3380CC4-5D6E-409C-BE32-E72D297353CC}">
+                <c16:uniqueId val="{00000009-315E-4F5F-9824-525B2026058B}"/>
+              </c:ext>
+            </c:extLst>
           </c:dPt>
           <c:cat>
             <c:strRef>
@@ -2944,26 +2994,6 @@
         </a:ln>
         <a:effectLst/>
       </c:spPr>
-      <c:txPr>
-        <a:bodyPr rot="0" spcFirstLastPara="1" vertOverflow="ellipsis" vert="horz" wrap="square" anchor="ctr" anchorCtr="1"/>
-        <a:lstStyle/>
-        <a:p>
-          <a:pPr>
-            <a:defRPr sz="1862" b="0" i="0" u="none" strike="noStrike" kern="1200" spc="0" baseline="0">
-              <a:solidFill>
-                <a:schemeClr val="tx1">
-                  <a:lumMod val="65000"/>
-                  <a:lumOff val="35000"/>
-                </a:schemeClr>
-              </a:solidFill>
-              <a:latin typeface="+mn-lt"/>
-              <a:ea typeface="+mn-ea"/>
-              <a:cs typeface="+mn-cs"/>
-            </a:defRPr>
-          </a:pPr>
-          <a:endParaRPr lang="en-US"/>
-        </a:p>
-      </c:txPr>
     </c:title>
     <c:autoTitleDeleted val="0"/>
     <c:view3D>
@@ -3682,26 +3712,6 @@
         </a:ln>
         <a:effectLst/>
       </c:spPr>
-      <c:txPr>
-        <a:bodyPr rot="0" spcFirstLastPara="1" vertOverflow="ellipsis" vert="horz" wrap="square" anchor="ctr" anchorCtr="1"/>
-        <a:lstStyle/>
-        <a:p>
-          <a:pPr>
-            <a:defRPr sz="1862" b="0" i="0" u="none" strike="noStrike" baseline="0">
-              <a:solidFill>
-                <a:schemeClr val="tx1">
-                  <a:lumMod val="65000"/>
-                  <a:lumOff val="35000"/>
-                </a:schemeClr>
-              </a:solidFill>
-              <a:latin typeface="+mn-lt"/>
-              <a:ea typeface="+mn-ea"/>
-              <a:cs typeface="+mn-cs"/>
-            </a:defRPr>
-          </a:pPr>
-          <a:endParaRPr lang="en-US"/>
-        </a:p>
-      </c:txPr>
     </c:title>
     <c:autoTitleDeleted val="0"/>
     <c:view3D>
@@ -13575,6 +13585,34 @@
           <a:chExt cx="0" cy="0"/>
         </a:xfrm>
       </p:grpSpPr>
+      <p:graphicFrame>
+        <p:nvGraphicFramePr>
+          <p:cNvPr id="3" name="Chart 2">
+            <a:extLst>
+              <a:ext uri="{FF2B5EF4-FFF2-40B4-BE49-F238E27FC236}">
+                <a16:creationId xmlns:a16="http://schemas.microsoft.com/office/drawing/2014/main" id="{515ACFE1-EF60-7436-4C27-DF35E131A5B5}"/>
+              </a:ext>
+            </a:extLst>
+          </p:cNvPr>
+          <p:cNvGraphicFramePr/>
+          <p:nvPr>
+            <p:extLst>
+              <p:ext uri="{D42A27DB-BD31-4B8C-83A1-F6EECF244321}">
+                <p14:modId xmlns:p14="http://schemas.microsoft.com/office/powerpoint/2010/main" val="4289439725"/>
+              </p:ext>
+            </p:extLst>
+          </p:nvPr>
+        </p:nvGraphicFramePr>
+        <p:xfrm>
+          <a:off x="952500" y="698500"/>
+          <a:ext cx="6858000" cy="3556000"/>
+        </p:xfrm>
+        <a:graphic>
+          <a:graphicData uri="http://schemas.openxmlformats.org/drawingml/2006/chart">
+            <c:chart xmlns:c="http://schemas.openxmlformats.org/drawingml/2006/chart" xmlns:r="http://schemas.openxmlformats.org/officeDocument/2006/relationships" r:id="rId2"/>
+          </a:graphicData>
+        </a:graphic>
+      </p:graphicFrame>
       <p:sp>
         <p:nvSpPr>
           <p:cNvPr id="2" name="TextBox 1">
@@ -13612,34 +13650,6 @@
           </a:p>
         </p:txBody>
       </p:sp>
-      <p:graphicFrame>
-        <p:nvGraphicFramePr>
-          <p:cNvPr id="3" name="Chart 2">
-            <a:extLst>
-              <a:ext uri="{FF2B5EF4-FFF2-40B4-BE49-F238E27FC236}">
-                <a16:creationId xmlns:a16="http://schemas.microsoft.com/office/drawing/2014/main" id="{515ACFE1-EF60-7436-4C27-DF35E131A5B5}"/>
-              </a:ext>
-            </a:extLst>
-          </p:cNvPr>
-          <p:cNvGraphicFramePr/>
-          <p:nvPr>
-            <p:extLst>
-              <p:ext uri="{D42A27DB-BD31-4B8C-83A1-F6EECF244321}">
-                <p14:modId xmlns:p14="http://schemas.microsoft.com/office/powerpoint/2010/main" val="4289439725"/>
-              </p:ext>
-            </p:extLst>
-          </p:nvPr>
-        </p:nvGraphicFramePr>
-        <p:xfrm>
-          <a:off x="952500" y="698500"/>
-          <a:ext cx="6858000" cy="3556000"/>
-        </p:xfrm>
-        <a:graphic>
-          <a:graphicData uri="http://schemas.openxmlformats.org/drawingml/2006/chart">
-            <c:chart xmlns:c="http://schemas.openxmlformats.org/drawingml/2006/chart" xmlns:r="http://schemas.openxmlformats.org/officeDocument/2006/relationships" r:id="rId2"/>
-          </a:graphicData>
-        </a:graphic>
-      </p:graphicFrame>
     </p:spTree>
     <p:extLst>
       <p:ext uri="{BB962C8B-B14F-4D97-AF65-F5344CB8AC3E}">
@@ -13670,43 +13680,6 @@
           <a:chExt cx="0" cy="0"/>
         </a:xfrm>
       </p:grpSpPr>
-      <p:sp>
-        <p:nvSpPr>
-          <p:cNvPr id="2" name="TextBox 1">
-            <a:extLst>
-              <a:ext uri="{FF2B5EF4-FFF2-40B4-BE49-F238E27FC236}">
-                <a16:creationId xmlns:a16="http://schemas.microsoft.com/office/drawing/2014/main" id="{70D2BFE3-0D18-42AE-B4C9-4759F57EBE0F}"/>
-              </a:ext>
-            </a:extLst>
-          </p:cNvPr>
-          <p:cNvSpPr txBox="1"/>
-          <p:nvPr/>
-        </p:nvSpPr>
-        <p:spPr>
-          <a:xfrm>
-            <a:off x="304800" y="152400"/>
-            <a:ext cx="8255000" cy="430887"/>
-          </a:xfrm>
-          <a:prstGeom prst="rect">
-            <a:avLst/>
-          </a:prstGeom>
-          <a:noFill/>
-        </p:spPr>
-        <p:txBody>
-          <a:bodyPr vert="horz" rtlCol="0">
-            <a:spAutoFit/>
-          </a:bodyPr>
-          <a:lstStyle/>
-          <a:p>
-            <a:r>
-              <a:rPr lang="en-US" sz="2200" b="1">
-                <a:latin typeface="Aptos Display" panose="020B0004020202020204" pitchFamily="34" charset="0"/>
-              </a:rPr>
-              <a:t>Microsoft PowerPoint producer: animation timeline</a:t>
-            </a:r>
-          </a:p>
-        </p:txBody>
-      </p:sp>
       <p:sp>
         <p:nvSpPr>
           <p:cNvPr id="3" name="Rectangle: Rounded Corners 2">
@@ -13759,6 +13732,43 @@
                 </a:solidFill>
               </a:rPr>
               <a:t>Rotate and motion effects</a:t>
+            </a:r>
+          </a:p>
+        </p:txBody>
+      </p:sp>
+      <p:sp>
+        <p:nvSpPr>
+          <p:cNvPr id="2" name="TextBox 1">
+            <a:extLst>
+              <a:ext uri="{FF2B5EF4-FFF2-40B4-BE49-F238E27FC236}">
+                <a16:creationId xmlns:a16="http://schemas.microsoft.com/office/drawing/2014/main" id="{70D2BFE3-0D18-42AE-B4C9-4759F57EBE0F}"/>
+              </a:ext>
+            </a:extLst>
+          </p:cNvPr>
+          <p:cNvSpPr txBox="1"/>
+          <p:nvPr/>
+        </p:nvSpPr>
+        <p:spPr>
+          <a:xfrm>
+            <a:off x="304800" y="152400"/>
+            <a:ext cx="8255000" cy="430887"/>
+          </a:xfrm>
+          <a:prstGeom prst="rect">
+            <a:avLst/>
+          </a:prstGeom>
+          <a:noFill/>
+        </p:spPr>
+        <p:txBody>
+          <a:bodyPr vert="horz" rtlCol="0">
+            <a:spAutoFit/>
+          </a:bodyPr>
+          <a:lstStyle/>
+          <a:p>
+            <a:r>
+              <a:rPr lang="en-US" sz="2200" b="1">
+                <a:latin typeface="Aptos Display" panose="020B0004020202020204" pitchFamily="34" charset="0"/>
+              </a:rPr>
+              <a:t>Microsoft PowerPoint producer: animation timeline</a:t>
             </a:r>
           </a:p>
         </p:txBody>
@@ -13922,7 +13932,7 @@
     </p:tnLst>
     <p:bldLst>
       <p:bldP spid="3" grpId="0" animBg="1"/>
-      <p:bldP spid="3" grpId="1"/>
+      <p:bldP spid="3" grpId="1" animBg="1"/>
       <p:bldP spid="3" grpId="2" animBg="1"/>
     </p:bldLst>
   </p:timing>
@@ -13946,43 +13956,6 @@
           <a:chExt cx="0" cy="0"/>
         </a:xfrm>
       </p:grpSpPr>
-      <p:sp>
-        <p:nvSpPr>
-          <p:cNvPr id="2" name="TextBox 1">
-            <a:extLst>
-              <a:ext uri="{FF2B5EF4-FFF2-40B4-BE49-F238E27FC236}">
-                <a16:creationId xmlns:a16="http://schemas.microsoft.com/office/drawing/2014/main" id="{4BFF8EFE-D549-CFB8-9130-A4EDFBC26661}"/>
-              </a:ext>
-            </a:extLst>
-          </p:cNvPr>
-          <p:cNvSpPr txBox="1"/>
-          <p:nvPr/>
-        </p:nvSpPr>
-        <p:spPr>
-          <a:xfrm>
-            <a:off x="304800" y="152400"/>
-            <a:ext cx="8255000" cy="769441"/>
-          </a:xfrm>
-          <a:prstGeom prst="rect">
-            <a:avLst/>
-          </a:prstGeom>
-          <a:noFill/>
-        </p:spPr>
-        <p:txBody>
-          <a:bodyPr vert="horz" rtlCol="0">
-            <a:spAutoFit/>
-          </a:bodyPr>
-          <a:lstStyle/>
-          <a:p>
-            <a:r>
-              <a:rPr lang="en-US" sz="2200" b="1">
-                <a:latin typeface="Aptos Display" panose="020B0004020202020204" pitchFamily="34" charset="0"/>
-              </a:rPr>
-              <a:t>Microsoft PowerPoint producer: embedded audio and playback metadata</a:t>
-            </a:r>
-          </a:p>
-        </p:txBody>
-      </p:sp>
       <p:pic>
         <p:nvPicPr>
           <p:cNvPr id="3" name="OfficeIMO embedded audio">
@@ -14052,6 +14025,43 @@
             <a:r>
               <a:rPr lang="en-US" sz="1600"/>
               <a:t>Embedded WAV source; OfficeIMO edits bytes and playback metadata.</a:t>
+            </a:r>
+          </a:p>
+        </p:txBody>
+      </p:sp>
+      <p:sp>
+        <p:nvSpPr>
+          <p:cNvPr id="2" name="TextBox 1">
+            <a:extLst>
+              <a:ext uri="{FF2B5EF4-FFF2-40B4-BE49-F238E27FC236}">
+                <a16:creationId xmlns:a16="http://schemas.microsoft.com/office/drawing/2014/main" id="{4BFF8EFE-D549-CFB8-9130-A4EDFBC26661}"/>
+              </a:ext>
+            </a:extLst>
+          </p:cNvPr>
+          <p:cNvSpPr txBox="1"/>
+          <p:nvPr/>
+        </p:nvSpPr>
+        <p:spPr>
+          <a:xfrm>
+            <a:off x="304800" y="152400"/>
+            <a:ext cx="8255000" cy="769441"/>
+          </a:xfrm>
+          <a:prstGeom prst="rect">
+            <a:avLst/>
+          </a:prstGeom>
+          <a:noFill/>
+        </p:spPr>
+        <p:txBody>
+          <a:bodyPr vert="horz" rtlCol="0">
+            <a:spAutoFit/>
+          </a:bodyPr>
+          <a:lstStyle/>
+          <a:p>
+            <a:r>
+              <a:rPr lang="en-US" sz="2200" b="1">
+                <a:latin typeface="Aptos Display" panose="020B0004020202020204" pitchFamily="34" charset="0"/>
+              </a:rPr>
+              <a:t>Microsoft PowerPoint producer: embedded audio and playback metadata</a:t>
             </a:r>
           </a:p>
         </p:txBody>
@@ -14173,6 +14183,34 @@
           <a:chExt cx="0" cy="0"/>
         </a:xfrm>
       </p:grpSpPr>
+      <p:graphicFrame>
+        <p:nvGraphicFramePr>
+          <p:cNvPr id="3" name="Chart 2">
+            <a:extLst>
+              <a:ext uri="{FF2B5EF4-FFF2-40B4-BE49-F238E27FC236}">
+                <a16:creationId xmlns:a16="http://schemas.microsoft.com/office/drawing/2014/main" id="{427D6D51-C030-514E-97CF-119912598007}"/>
+              </a:ext>
+            </a:extLst>
+          </p:cNvPr>
+          <p:cNvGraphicFramePr/>
+          <p:nvPr>
+            <p:extLst>
+              <p:ext uri="{D42A27DB-BD31-4B8C-83A1-F6EECF244321}">
+                <p14:modId xmlns:p14="http://schemas.microsoft.com/office/powerpoint/2010/main" val="104626297"/>
+              </p:ext>
+            </p:extLst>
+          </p:nvPr>
+        </p:nvGraphicFramePr>
+        <p:xfrm>
+          <a:off x="952500" y="698500"/>
+          <a:ext cx="6858000" cy="3556000"/>
+        </p:xfrm>
+        <a:graphic>
+          <a:graphicData uri="http://schemas.openxmlformats.org/drawingml/2006/chart">
+            <c:chart xmlns:c="http://schemas.openxmlformats.org/drawingml/2006/chart" xmlns:r="http://schemas.openxmlformats.org/officeDocument/2006/relationships" r:id="rId2"/>
+          </a:graphicData>
+        </a:graphic>
+      </p:graphicFrame>
       <p:sp>
         <p:nvSpPr>
           <p:cNvPr id="2" name="TextBox 1">
@@ -14210,34 +14248,6 @@
           </a:p>
         </p:txBody>
       </p:sp>
-      <p:graphicFrame>
-        <p:nvGraphicFramePr>
-          <p:cNvPr id="3" name="Chart 2">
-            <a:extLst>
-              <a:ext uri="{FF2B5EF4-FFF2-40B4-BE49-F238E27FC236}">
-                <a16:creationId xmlns:a16="http://schemas.microsoft.com/office/drawing/2014/main" id="{427D6D51-C030-514E-97CF-119912598007}"/>
-              </a:ext>
-            </a:extLst>
-          </p:cNvPr>
-          <p:cNvGraphicFramePr/>
-          <p:nvPr>
-            <p:extLst>
-              <p:ext uri="{D42A27DB-BD31-4B8C-83A1-F6EECF244321}">
-                <p14:modId xmlns:p14="http://schemas.microsoft.com/office/powerpoint/2010/main" val="104626297"/>
-              </p:ext>
-            </p:extLst>
-          </p:nvPr>
-        </p:nvGraphicFramePr>
-        <p:xfrm>
-          <a:off x="952500" y="698500"/>
-          <a:ext cx="6858000" cy="3556000"/>
-        </p:xfrm>
-        <a:graphic>
-          <a:graphicData uri="http://schemas.openxmlformats.org/drawingml/2006/chart">
-            <c:chart xmlns:c="http://schemas.openxmlformats.org/drawingml/2006/chart" xmlns:r="http://schemas.openxmlformats.org/officeDocument/2006/relationships" r:id="rId2"/>
-          </a:graphicData>
-        </a:graphic>
-      </p:graphicFrame>
     </p:spTree>
     <p:extLst>
       <p:ext uri="{BB962C8B-B14F-4D97-AF65-F5344CB8AC3E}">
@@ -14268,6 +14278,34 @@
           <a:chExt cx="0" cy="0"/>
         </a:xfrm>
       </p:grpSpPr>
+      <p:graphicFrame>
+        <p:nvGraphicFramePr>
+          <p:cNvPr id="3" name="Chart 2">
+            <a:extLst>
+              <a:ext uri="{FF2B5EF4-FFF2-40B4-BE49-F238E27FC236}">
+                <a16:creationId xmlns:a16="http://schemas.microsoft.com/office/drawing/2014/main" id="{5A8C92E4-E59A-F02C-DDB6-AC31AF89581C}"/>
+              </a:ext>
+            </a:extLst>
+          </p:cNvPr>
+          <p:cNvGraphicFramePr/>
+          <p:nvPr>
+            <p:extLst>
+              <p:ext uri="{D42A27DB-BD31-4B8C-83A1-F6EECF244321}">
+                <p14:modId xmlns:p14="http://schemas.microsoft.com/office/powerpoint/2010/main" val="516727913"/>
+              </p:ext>
+            </p:extLst>
+          </p:nvPr>
+        </p:nvGraphicFramePr>
+        <p:xfrm>
+          <a:off x="952500" y="698500"/>
+          <a:ext cx="6858000" cy="3556000"/>
+        </p:xfrm>
+        <a:graphic>
+          <a:graphicData uri="http://schemas.openxmlformats.org/drawingml/2006/chart">
+            <c:chart xmlns:c="http://schemas.openxmlformats.org/drawingml/2006/chart" xmlns:r="http://schemas.openxmlformats.org/officeDocument/2006/relationships" r:id="rId2"/>
+          </a:graphicData>
+        </a:graphic>
+      </p:graphicFrame>
       <p:sp>
         <p:nvSpPr>
           <p:cNvPr id="2" name="TextBox 1">
@@ -14305,34 +14343,6 @@
           </a:p>
         </p:txBody>
       </p:sp>
-      <p:graphicFrame>
-        <p:nvGraphicFramePr>
-          <p:cNvPr id="3" name="Chart 2">
-            <a:extLst>
-              <a:ext uri="{FF2B5EF4-FFF2-40B4-BE49-F238E27FC236}">
-                <a16:creationId xmlns:a16="http://schemas.microsoft.com/office/drawing/2014/main" id="{5A8C92E4-E59A-F02C-DDB6-AC31AF89581C}"/>
-              </a:ext>
-            </a:extLst>
-          </p:cNvPr>
-          <p:cNvGraphicFramePr/>
-          <p:nvPr>
-            <p:extLst>
-              <p:ext uri="{D42A27DB-BD31-4B8C-83A1-F6EECF244321}">
-                <p14:modId xmlns:p14="http://schemas.microsoft.com/office/powerpoint/2010/main" val="516727913"/>
-              </p:ext>
-            </p:extLst>
-          </p:nvPr>
-        </p:nvGraphicFramePr>
-        <p:xfrm>
-          <a:off x="952500" y="698500"/>
-          <a:ext cx="6858000" cy="3556000"/>
-        </p:xfrm>
-        <a:graphic>
-          <a:graphicData uri="http://schemas.openxmlformats.org/drawingml/2006/chart">
-            <c:chart xmlns:c="http://schemas.openxmlformats.org/drawingml/2006/chart" xmlns:r="http://schemas.openxmlformats.org/officeDocument/2006/relationships" r:id="rId2"/>
-          </a:graphicData>
-        </a:graphic>
-      </p:graphicFrame>
     </p:spTree>
     <p:extLst>
       <p:ext uri="{BB962C8B-B14F-4D97-AF65-F5344CB8AC3E}">
@@ -14363,6 +14373,34 @@
           <a:chExt cx="0" cy="0"/>
         </a:xfrm>
       </p:grpSpPr>
+      <p:graphicFrame>
+        <p:nvGraphicFramePr>
+          <p:cNvPr id="3" name="Chart 2">
+            <a:extLst>
+              <a:ext uri="{FF2B5EF4-FFF2-40B4-BE49-F238E27FC236}">
+                <a16:creationId xmlns:a16="http://schemas.microsoft.com/office/drawing/2014/main" id="{70D2E591-82F8-6DAF-58D1-CE5B7005D304}"/>
+              </a:ext>
+            </a:extLst>
+          </p:cNvPr>
+          <p:cNvGraphicFramePr/>
+          <p:nvPr>
+            <p:extLst>
+              <p:ext uri="{D42A27DB-BD31-4B8C-83A1-F6EECF244321}">
+                <p14:modId xmlns:p14="http://schemas.microsoft.com/office/powerpoint/2010/main" val="3755532164"/>
+              </p:ext>
+            </p:extLst>
+          </p:nvPr>
+        </p:nvGraphicFramePr>
+        <p:xfrm>
+          <a:off x="952500" y="698500"/>
+          <a:ext cx="6858000" cy="3556000"/>
+        </p:xfrm>
+        <a:graphic>
+          <a:graphicData uri="http://schemas.openxmlformats.org/drawingml/2006/chart">
+            <c:chart xmlns:c="http://schemas.openxmlformats.org/drawingml/2006/chart" xmlns:r="http://schemas.openxmlformats.org/officeDocument/2006/relationships" r:id="rId2"/>
+          </a:graphicData>
+        </a:graphic>
+      </p:graphicFrame>
       <p:sp>
         <p:nvSpPr>
           <p:cNvPr id="2" name="TextBox 1">
@@ -14400,34 +14438,6 @@
           </a:p>
         </p:txBody>
       </p:sp>
-      <p:graphicFrame>
-        <p:nvGraphicFramePr>
-          <p:cNvPr id="3" name="Chart 2">
-            <a:extLst>
-              <a:ext uri="{FF2B5EF4-FFF2-40B4-BE49-F238E27FC236}">
-                <a16:creationId xmlns:a16="http://schemas.microsoft.com/office/drawing/2014/main" id="{70D2E591-82F8-6DAF-58D1-CE5B7005D304}"/>
-              </a:ext>
-            </a:extLst>
-          </p:cNvPr>
-          <p:cNvGraphicFramePr/>
-          <p:nvPr>
-            <p:extLst>
-              <p:ext uri="{D42A27DB-BD31-4B8C-83A1-F6EECF244321}">
-                <p14:modId xmlns:p14="http://schemas.microsoft.com/office/powerpoint/2010/main" val="3755532164"/>
-              </p:ext>
-            </p:extLst>
-          </p:nvPr>
-        </p:nvGraphicFramePr>
-        <p:xfrm>
-          <a:off x="952500" y="698500"/>
-          <a:ext cx="6858000" cy="3556000"/>
-        </p:xfrm>
-        <a:graphic>
-          <a:graphicData uri="http://schemas.openxmlformats.org/drawingml/2006/chart">
-            <c:chart xmlns:c="http://schemas.openxmlformats.org/drawingml/2006/chart" xmlns:r="http://schemas.openxmlformats.org/officeDocument/2006/relationships" r:id="rId2"/>
-          </a:graphicData>
-        </a:graphic>
-      </p:graphicFrame>
     </p:spTree>
     <p:extLst>
       <p:ext uri="{BB962C8B-B14F-4D97-AF65-F5344CB8AC3E}">
@@ -14458,6 +14468,34 @@
           <a:chExt cx="0" cy="0"/>
         </a:xfrm>
       </p:grpSpPr>
+      <p:graphicFrame>
+        <p:nvGraphicFramePr>
+          <p:cNvPr id="3" name="Chart 2">
+            <a:extLst>
+              <a:ext uri="{FF2B5EF4-FFF2-40B4-BE49-F238E27FC236}">
+                <a16:creationId xmlns:a16="http://schemas.microsoft.com/office/drawing/2014/main" id="{95739B26-5817-45F1-DE54-423D518658AC}"/>
+              </a:ext>
+            </a:extLst>
+          </p:cNvPr>
+          <p:cNvGraphicFramePr/>
+          <p:nvPr>
+            <p:extLst>
+              <p:ext uri="{D42A27DB-BD31-4B8C-83A1-F6EECF244321}">
+                <p14:modId xmlns:p14="http://schemas.microsoft.com/office/powerpoint/2010/main" val="3033920728"/>
+              </p:ext>
+            </p:extLst>
+          </p:nvPr>
+        </p:nvGraphicFramePr>
+        <p:xfrm>
+          <a:off x="952500" y="698500"/>
+          <a:ext cx="6858000" cy="3556000"/>
+        </p:xfrm>
+        <a:graphic>
+          <a:graphicData uri="http://schemas.openxmlformats.org/drawingml/2006/chart">
+            <c:chart xmlns:c="http://schemas.openxmlformats.org/drawingml/2006/chart" xmlns:r="http://schemas.openxmlformats.org/officeDocument/2006/relationships" r:id="rId2"/>
+          </a:graphicData>
+        </a:graphic>
+      </p:graphicFrame>
       <p:sp>
         <p:nvSpPr>
           <p:cNvPr id="2" name="TextBox 1">
@@ -14495,34 +14533,6 @@
           </a:p>
         </p:txBody>
       </p:sp>
-      <p:graphicFrame>
-        <p:nvGraphicFramePr>
-          <p:cNvPr id="3" name="Chart 2">
-            <a:extLst>
-              <a:ext uri="{FF2B5EF4-FFF2-40B4-BE49-F238E27FC236}">
-                <a16:creationId xmlns:a16="http://schemas.microsoft.com/office/drawing/2014/main" id="{95739B26-5817-45F1-DE54-423D518658AC}"/>
-              </a:ext>
-            </a:extLst>
-          </p:cNvPr>
-          <p:cNvGraphicFramePr/>
-          <p:nvPr>
-            <p:extLst>
-              <p:ext uri="{D42A27DB-BD31-4B8C-83A1-F6EECF244321}">
-                <p14:modId xmlns:p14="http://schemas.microsoft.com/office/powerpoint/2010/main" val="3033920728"/>
-              </p:ext>
-            </p:extLst>
-          </p:nvPr>
-        </p:nvGraphicFramePr>
-        <p:xfrm>
-          <a:off x="952500" y="698500"/>
-          <a:ext cx="6858000" cy="3556000"/>
-        </p:xfrm>
-        <a:graphic>
-          <a:graphicData uri="http://schemas.openxmlformats.org/drawingml/2006/chart">
-            <c:chart xmlns:c="http://schemas.openxmlformats.org/drawingml/2006/chart" xmlns:r="http://schemas.openxmlformats.org/officeDocument/2006/relationships" r:id="rId2"/>
-          </a:graphicData>
-        </a:graphic>
-      </p:graphicFrame>
     </p:spTree>
     <p:extLst>
       <p:ext uri="{BB962C8B-B14F-4D97-AF65-F5344CB8AC3E}">
@@ -14553,6 +14563,34 @@
           <a:chExt cx="0" cy="0"/>
         </a:xfrm>
       </p:grpSpPr>
+      <p:graphicFrame>
+        <p:nvGraphicFramePr>
+          <p:cNvPr id="3" name="Chart 2">
+            <a:extLst>
+              <a:ext uri="{FF2B5EF4-FFF2-40B4-BE49-F238E27FC236}">
+                <a16:creationId xmlns:a16="http://schemas.microsoft.com/office/drawing/2014/main" id="{11AF0118-DC3B-E7EB-EEF3-2867AF3C74CB}"/>
+              </a:ext>
+            </a:extLst>
+          </p:cNvPr>
+          <p:cNvGraphicFramePr/>
+          <p:nvPr>
+            <p:extLst>
+              <p:ext uri="{D42A27DB-BD31-4B8C-83A1-F6EECF244321}">
+                <p14:modId xmlns:p14="http://schemas.microsoft.com/office/powerpoint/2010/main" val="366672567"/>
+              </p:ext>
+            </p:extLst>
+          </p:nvPr>
+        </p:nvGraphicFramePr>
+        <p:xfrm>
+          <a:off x="952500" y="698500"/>
+          <a:ext cx="6858000" cy="3556000"/>
+        </p:xfrm>
+        <a:graphic>
+          <a:graphicData uri="http://schemas.openxmlformats.org/drawingml/2006/chart">
+            <c:chart xmlns:c="http://schemas.openxmlformats.org/drawingml/2006/chart" xmlns:r="http://schemas.openxmlformats.org/officeDocument/2006/relationships" r:id="rId2"/>
+          </a:graphicData>
+        </a:graphic>
+      </p:graphicFrame>
       <p:sp>
         <p:nvSpPr>
           <p:cNvPr id="2" name="TextBox 1">
@@ -14590,34 +14628,6 @@
           </a:p>
         </p:txBody>
       </p:sp>
-      <p:graphicFrame>
-        <p:nvGraphicFramePr>
-          <p:cNvPr id="3" name="Chart 2">
-            <a:extLst>
-              <a:ext uri="{FF2B5EF4-FFF2-40B4-BE49-F238E27FC236}">
-                <a16:creationId xmlns:a16="http://schemas.microsoft.com/office/drawing/2014/main" id="{11AF0118-DC3B-E7EB-EEF3-2867AF3C74CB}"/>
-              </a:ext>
-            </a:extLst>
-          </p:cNvPr>
-          <p:cNvGraphicFramePr/>
-          <p:nvPr>
-            <p:extLst>
-              <p:ext uri="{D42A27DB-BD31-4B8C-83A1-F6EECF244321}">
-                <p14:modId xmlns:p14="http://schemas.microsoft.com/office/powerpoint/2010/main" val="366672567"/>
-              </p:ext>
-            </p:extLst>
-          </p:nvPr>
-        </p:nvGraphicFramePr>
-        <p:xfrm>
-          <a:off x="952500" y="698500"/>
-          <a:ext cx="6858000" cy="3556000"/>
-        </p:xfrm>
-        <a:graphic>
-          <a:graphicData uri="http://schemas.openxmlformats.org/drawingml/2006/chart">
-            <c:chart xmlns:c="http://schemas.openxmlformats.org/drawingml/2006/chart" xmlns:r="http://schemas.openxmlformats.org/officeDocument/2006/relationships" r:id="rId2"/>
-          </a:graphicData>
-        </a:graphic>
-      </p:graphicFrame>
     </p:spTree>
     <p:extLst>
       <p:ext uri="{BB962C8B-B14F-4D97-AF65-F5344CB8AC3E}">
@@ -14648,6 +14658,34 @@
           <a:chExt cx="0" cy="0"/>
         </a:xfrm>
       </p:grpSpPr>
+      <p:graphicFrame>
+        <p:nvGraphicFramePr>
+          <p:cNvPr id="3" name="Chart 2">
+            <a:extLst>
+              <a:ext uri="{FF2B5EF4-FFF2-40B4-BE49-F238E27FC236}">
+                <a16:creationId xmlns:a16="http://schemas.microsoft.com/office/drawing/2014/main" id="{A280BA27-511A-11D5-81A6-E76EE6AC5456}"/>
+              </a:ext>
+            </a:extLst>
+          </p:cNvPr>
+          <p:cNvGraphicFramePr/>
+          <p:nvPr>
+            <p:extLst>
+              <p:ext uri="{D42A27DB-BD31-4B8C-83A1-F6EECF244321}">
+                <p14:modId xmlns:p14="http://schemas.microsoft.com/office/powerpoint/2010/main" val="125908383"/>
+              </p:ext>
+            </p:extLst>
+          </p:nvPr>
+        </p:nvGraphicFramePr>
+        <p:xfrm>
+          <a:off x="952500" y="698500"/>
+          <a:ext cx="6858000" cy="3556000"/>
+        </p:xfrm>
+        <a:graphic>
+          <a:graphicData uri="http://schemas.openxmlformats.org/drawingml/2006/chart">
+            <c:chart xmlns:c="http://schemas.openxmlformats.org/drawingml/2006/chart" xmlns:r="http://schemas.openxmlformats.org/officeDocument/2006/relationships" r:id="rId2"/>
+          </a:graphicData>
+        </a:graphic>
+      </p:graphicFrame>
       <p:sp>
         <p:nvSpPr>
           <p:cNvPr id="2" name="TextBox 1">
@@ -14685,34 +14723,6 @@
           </a:p>
         </p:txBody>
       </p:sp>
-      <p:graphicFrame>
-        <p:nvGraphicFramePr>
-          <p:cNvPr id="3" name="Chart 2">
-            <a:extLst>
-              <a:ext uri="{FF2B5EF4-FFF2-40B4-BE49-F238E27FC236}">
-                <a16:creationId xmlns:a16="http://schemas.microsoft.com/office/drawing/2014/main" id="{A280BA27-511A-11D5-81A6-E76EE6AC5456}"/>
-              </a:ext>
-            </a:extLst>
-          </p:cNvPr>
-          <p:cNvGraphicFramePr/>
-          <p:nvPr>
-            <p:extLst>
-              <p:ext uri="{D42A27DB-BD31-4B8C-83A1-F6EECF244321}">
-                <p14:modId xmlns:p14="http://schemas.microsoft.com/office/powerpoint/2010/main" val="125908383"/>
-              </p:ext>
-            </p:extLst>
-          </p:nvPr>
-        </p:nvGraphicFramePr>
-        <p:xfrm>
-          <a:off x="952500" y="698500"/>
-          <a:ext cx="6858000" cy="3556000"/>
-        </p:xfrm>
-        <a:graphic>
-          <a:graphicData uri="http://schemas.openxmlformats.org/drawingml/2006/chart">
-            <c:chart xmlns:c="http://schemas.openxmlformats.org/drawingml/2006/chart" xmlns:r="http://schemas.openxmlformats.org/officeDocument/2006/relationships" r:id="rId2"/>
-          </a:graphicData>
-        </a:graphic>
-      </p:graphicFrame>
     </p:spTree>
     <p:extLst>
       <p:ext uri="{BB962C8B-B14F-4D97-AF65-F5344CB8AC3E}">
@@ -14743,6 +14753,34 @@
           <a:chExt cx="0" cy="0"/>
         </a:xfrm>
       </p:grpSpPr>
+      <p:graphicFrame>
+        <p:nvGraphicFramePr>
+          <p:cNvPr id="3" name="Chart 2">
+            <a:extLst>
+              <a:ext uri="{FF2B5EF4-FFF2-40B4-BE49-F238E27FC236}">
+                <a16:creationId xmlns:a16="http://schemas.microsoft.com/office/drawing/2014/main" id="{36AA72E2-0634-5CD6-B5D7-E1BA05603B0A}"/>
+              </a:ext>
+            </a:extLst>
+          </p:cNvPr>
+          <p:cNvGraphicFramePr/>
+          <p:nvPr>
+            <p:extLst>
+              <p:ext uri="{D42A27DB-BD31-4B8C-83A1-F6EECF244321}">
+                <p14:modId xmlns:p14="http://schemas.microsoft.com/office/powerpoint/2010/main" val="192366229"/>
+              </p:ext>
+            </p:extLst>
+          </p:nvPr>
+        </p:nvGraphicFramePr>
+        <p:xfrm>
+          <a:off x="952500" y="698500"/>
+          <a:ext cx="6858000" cy="3556000"/>
+        </p:xfrm>
+        <a:graphic>
+          <a:graphicData uri="http://schemas.openxmlformats.org/drawingml/2006/chart">
+            <c:chart xmlns:c="http://schemas.openxmlformats.org/drawingml/2006/chart" xmlns:r="http://schemas.openxmlformats.org/officeDocument/2006/relationships" r:id="rId2"/>
+          </a:graphicData>
+        </a:graphic>
+      </p:graphicFrame>
       <p:sp>
         <p:nvSpPr>
           <p:cNvPr id="2" name="TextBox 1">
@@ -14780,34 +14818,6 @@
           </a:p>
         </p:txBody>
       </p:sp>
-      <p:graphicFrame>
-        <p:nvGraphicFramePr>
-          <p:cNvPr id="3" name="Chart 2">
-            <a:extLst>
-              <a:ext uri="{FF2B5EF4-FFF2-40B4-BE49-F238E27FC236}">
-                <a16:creationId xmlns:a16="http://schemas.microsoft.com/office/drawing/2014/main" id="{36AA72E2-0634-5CD6-B5D7-E1BA05603B0A}"/>
-              </a:ext>
-            </a:extLst>
-          </p:cNvPr>
-          <p:cNvGraphicFramePr/>
-          <p:nvPr>
-            <p:extLst>
-              <p:ext uri="{D42A27DB-BD31-4B8C-83A1-F6EECF244321}">
-                <p14:modId xmlns:p14="http://schemas.microsoft.com/office/powerpoint/2010/main" val="192366229"/>
-              </p:ext>
-            </p:extLst>
-          </p:nvPr>
-        </p:nvGraphicFramePr>
-        <p:xfrm>
-          <a:off x="952500" y="698500"/>
-          <a:ext cx="6858000" cy="3556000"/>
-        </p:xfrm>
-        <a:graphic>
-          <a:graphicData uri="http://schemas.openxmlformats.org/drawingml/2006/chart">
-            <c:chart xmlns:c="http://schemas.openxmlformats.org/drawingml/2006/chart" xmlns:r="http://schemas.openxmlformats.org/officeDocument/2006/relationships" r:id="rId2"/>
-          </a:graphicData>
-        </a:graphic>
-      </p:graphicFrame>
     </p:spTree>
     <p:extLst>
       <p:ext uri="{BB962C8B-B14F-4D97-AF65-F5344CB8AC3E}">
@@ -14838,6 +14848,34 @@
           <a:chExt cx="0" cy="0"/>
         </a:xfrm>
       </p:grpSpPr>
+      <p:graphicFrame>
+        <p:nvGraphicFramePr>
+          <p:cNvPr id="3" name="Diagram 2">
+            <a:extLst>
+              <a:ext uri="{FF2B5EF4-FFF2-40B4-BE49-F238E27FC236}">
+                <a16:creationId xmlns:a16="http://schemas.microsoft.com/office/drawing/2014/main" id="{1ECF56DA-F420-561D-5B15-D879D52903A2}"/>
+              </a:ext>
+            </a:extLst>
+          </p:cNvPr>
+          <p:cNvGraphicFramePr/>
+          <p:nvPr>
+            <p:extLst>
+              <p:ext uri="{D42A27DB-BD31-4B8C-83A1-F6EECF244321}">
+                <p14:modId xmlns:p14="http://schemas.microsoft.com/office/powerpoint/2010/main" val="3868431994"/>
+              </p:ext>
+            </p:extLst>
+          </p:nvPr>
+        </p:nvGraphicFramePr>
+        <p:xfrm>
+          <a:off x="762000" y="1079500"/>
+          <a:ext cx="7620000" cy="2667000"/>
+        </p:xfrm>
+        <a:graphic>
+          <a:graphicData uri="http://schemas.openxmlformats.org/drawingml/2006/diagram">
+            <dgm:relIds xmlns:dgm="http://schemas.openxmlformats.org/drawingml/2006/diagram" xmlns:r="http://schemas.openxmlformats.org/officeDocument/2006/relationships" r:dm="rId2" r:lo="rId3" r:qs="rId4" r:cs="rId5"/>
+          </a:graphicData>
+        </a:graphic>
+      </p:graphicFrame>
       <p:sp>
         <p:nvSpPr>
           <p:cNvPr id="2" name="TextBox 1">
@@ -14875,34 +14913,6 @@
           </a:p>
         </p:txBody>
       </p:sp>
-      <p:graphicFrame>
-        <p:nvGraphicFramePr>
-          <p:cNvPr id="3" name="Diagram 2">
-            <a:extLst>
-              <a:ext uri="{FF2B5EF4-FFF2-40B4-BE49-F238E27FC236}">
-                <a16:creationId xmlns:a16="http://schemas.microsoft.com/office/drawing/2014/main" id="{1ECF56DA-F420-561D-5B15-D879D52903A2}"/>
-              </a:ext>
-            </a:extLst>
-          </p:cNvPr>
-          <p:cNvGraphicFramePr/>
-          <p:nvPr>
-            <p:extLst>
-              <p:ext uri="{D42A27DB-BD31-4B8C-83A1-F6EECF244321}">
-                <p14:modId xmlns:p14="http://schemas.microsoft.com/office/powerpoint/2010/main" val="3868431994"/>
-              </p:ext>
-            </p:extLst>
-          </p:nvPr>
-        </p:nvGraphicFramePr>
-        <p:xfrm>
-          <a:off x="762000" y="1079500"/>
-          <a:ext cx="7620000" cy="2667000"/>
-        </p:xfrm>
-        <a:graphic>
-          <a:graphicData uri="http://schemas.openxmlformats.org/drawingml/2006/diagram">
-            <dgm:relIds xmlns:dgm="http://schemas.openxmlformats.org/drawingml/2006/diagram" xmlns:r="http://schemas.openxmlformats.org/officeDocument/2006/relationships" r:dm="rId2" r:lo="rId3" r:qs="rId4" r:cs="rId5"/>
-          </a:graphicData>
-        </a:graphic>
-      </p:graphicFrame>
     </p:spTree>
     <p:extLst>
       <p:ext uri="{BB962C8B-B14F-4D97-AF65-F5344CB8AC3E}">

</xml_diff>